<commit_message>
Feat: Ecfp6 xgboost model trained and saved. xgboost_base_model.py running succesfully. Model metrics saved, show mediocre mean-mcc of 0.22
</commit_message>
<xml_diff>
--- a/Figuras/Diagrams TFM.pptx
+++ b/Figuras/Diagrams TFM.pptx
@@ -198,7 +198,7 @@
           <a:p>
             <a:fld id="{D15AD191-481F-47CD-BB31-6284BAB9F5F2}" type="datetimeFigureOut">
               <a:rPr lang="en-GB" smtClean="0"/>
-              <a:t>15/04/2026</a:t>
+              <a:t>05/05/2026</a:t>
             </a:fld>
             <a:endParaRPr lang="en-GB"/>
           </a:p>
@@ -889,7 +889,7 @@
           <a:p>
             <a:fld id="{76EE70CD-0C52-4877-95B4-2234339B47C2}" type="datetimeFigureOut">
               <a:rPr lang="en-GB" smtClean="0"/>
-              <a:t>15/04/2026</a:t>
+              <a:t>05/05/2026</a:t>
             </a:fld>
             <a:endParaRPr lang="en-GB"/>
           </a:p>
@@ -1087,7 +1087,7 @@
           <a:p>
             <a:fld id="{76EE70CD-0C52-4877-95B4-2234339B47C2}" type="datetimeFigureOut">
               <a:rPr lang="en-GB" smtClean="0"/>
-              <a:t>15/04/2026</a:t>
+              <a:t>05/05/2026</a:t>
             </a:fld>
             <a:endParaRPr lang="en-GB"/>
           </a:p>
@@ -1295,7 +1295,7 @@
           <a:p>
             <a:fld id="{76EE70CD-0C52-4877-95B4-2234339B47C2}" type="datetimeFigureOut">
               <a:rPr lang="en-GB" smtClean="0"/>
-              <a:t>15/04/2026</a:t>
+              <a:t>05/05/2026</a:t>
             </a:fld>
             <a:endParaRPr lang="en-GB"/>
           </a:p>
@@ -1493,7 +1493,7 @@
           <a:p>
             <a:fld id="{76EE70CD-0C52-4877-95B4-2234339B47C2}" type="datetimeFigureOut">
               <a:rPr lang="en-GB" smtClean="0"/>
-              <a:t>15/04/2026</a:t>
+              <a:t>05/05/2026</a:t>
             </a:fld>
             <a:endParaRPr lang="en-GB"/>
           </a:p>
@@ -1768,7 +1768,7 @@
           <a:p>
             <a:fld id="{76EE70CD-0C52-4877-95B4-2234339B47C2}" type="datetimeFigureOut">
               <a:rPr lang="en-GB" smtClean="0"/>
-              <a:t>15/04/2026</a:t>
+              <a:t>05/05/2026</a:t>
             </a:fld>
             <a:endParaRPr lang="en-GB"/>
           </a:p>
@@ -2033,7 +2033,7 @@
           <a:p>
             <a:fld id="{76EE70CD-0C52-4877-95B4-2234339B47C2}" type="datetimeFigureOut">
               <a:rPr lang="en-GB" smtClean="0"/>
-              <a:t>15/04/2026</a:t>
+              <a:t>05/05/2026</a:t>
             </a:fld>
             <a:endParaRPr lang="en-GB"/>
           </a:p>
@@ -2445,7 +2445,7 @@
           <a:p>
             <a:fld id="{76EE70CD-0C52-4877-95B4-2234339B47C2}" type="datetimeFigureOut">
               <a:rPr lang="en-GB" smtClean="0"/>
-              <a:t>15/04/2026</a:t>
+              <a:t>05/05/2026</a:t>
             </a:fld>
             <a:endParaRPr lang="en-GB"/>
           </a:p>
@@ -2586,7 +2586,7 @@
           <a:p>
             <a:fld id="{76EE70CD-0C52-4877-95B4-2234339B47C2}" type="datetimeFigureOut">
               <a:rPr lang="en-GB" smtClean="0"/>
-              <a:t>15/04/2026</a:t>
+              <a:t>05/05/2026</a:t>
             </a:fld>
             <a:endParaRPr lang="en-GB"/>
           </a:p>
@@ -2699,7 +2699,7 @@
           <a:p>
             <a:fld id="{76EE70CD-0C52-4877-95B4-2234339B47C2}" type="datetimeFigureOut">
               <a:rPr lang="en-GB" smtClean="0"/>
-              <a:t>15/04/2026</a:t>
+              <a:t>05/05/2026</a:t>
             </a:fld>
             <a:endParaRPr lang="en-GB"/>
           </a:p>
@@ -3010,7 +3010,7 @@
           <a:p>
             <a:fld id="{76EE70CD-0C52-4877-95B4-2234339B47C2}" type="datetimeFigureOut">
               <a:rPr lang="en-GB" smtClean="0"/>
-              <a:t>15/04/2026</a:t>
+              <a:t>05/05/2026</a:t>
             </a:fld>
             <a:endParaRPr lang="en-GB"/>
           </a:p>
@@ -3298,7 +3298,7 @@
           <a:p>
             <a:fld id="{76EE70CD-0C52-4877-95B4-2234339B47C2}" type="datetimeFigureOut">
               <a:rPr lang="en-GB" smtClean="0"/>
-              <a:t>15/04/2026</a:t>
+              <a:t>05/05/2026</a:t>
             </a:fld>
             <a:endParaRPr lang="en-GB"/>
           </a:p>
@@ -3539,7 +3539,7 @@
           <a:p>
             <a:fld id="{76EE70CD-0C52-4877-95B4-2234339B47C2}" type="datetimeFigureOut">
               <a:rPr lang="en-GB" smtClean="0"/>
-              <a:t>15/04/2026</a:t>
+              <a:t>05/05/2026</a:t>
             </a:fld>
             <a:endParaRPr lang="en-GB"/>
           </a:p>
@@ -8932,10 +8932,10 @@
         </p:nvGrpSpPr>
         <p:grpSpPr>
           <a:xfrm>
-            <a:off x="5392664" y="2836104"/>
-            <a:ext cx="5408529" cy="1227381"/>
-            <a:chOff x="5392664" y="2836104"/>
-            <a:chExt cx="5408529" cy="1227381"/>
+            <a:off x="5395913" y="2787802"/>
+            <a:ext cx="5405280" cy="1275683"/>
+            <a:chOff x="5395913" y="2787802"/>
+            <a:chExt cx="5405280" cy="1275683"/>
           </a:xfrm>
         </p:grpSpPr>
         <p:pic>
@@ -8954,14 +8954,15 @@
           </p:nvPicPr>
           <p:blipFill>
             <a:blip r:embed="rId18"/>
+            <a:srcRect l="20653" t="17246" r="20193" b="21185"/>
             <a:stretch>
               <a:fillRect/>
             </a:stretch>
           </p:blipFill>
           <p:spPr>
             <a:xfrm>
-              <a:off x="5392664" y="2836104"/>
-              <a:ext cx="1003307" cy="907911"/>
+              <a:off x="5417737" y="2787802"/>
+              <a:ext cx="1071242" cy="1008986"/>
             </a:xfrm>
             <a:prstGeom prst="rect">
               <a:avLst/>
@@ -8984,14 +8985,15 @@
           </p:nvPicPr>
           <p:blipFill>
             <a:blip r:embed="rId19"/>
+            <a:srcRect l="12543" t="8311" r="6445" b="10092"/>
             <a:stretch>
               <a:fillRect/>
             </a:stretch>
           </p:blipFill>
           <p:spPr>
             <a:xfrm>
-              <a:off x="9408222" y="2877502"/>
-              <a:ext cx="1049161" cy="888087"/>
+              <a:off x="9426773" y="2886795"/>
+              <a:ext cx="1000995" cy="853441"/>
             </a:xfrm>
             <a:prstGeom prst="rect">
               <a:avLst/>
@@ -9014,14 +9016,15 @@
           </p:nvPicPr>
           <p:blipFill>
             <a:blip r:embed="rId20"/>
+            <a:srcRect r="23290" b="18453"/>
             <a:stretch>
               <a:fillRect/>
             </a:stretch>
           </p:blipFill>
           <p:spPr>
             <a:xfrm>
-              <a:off x="8534663" y="2952481"/>
-              <a:ext cx="956235" cy="824037"/>
+              <a:off x="8398031" y="2877753"/>
+              <a:ext cx="979566" cy="897372"/>
             </a:xfrm>
             <a:prstGeom prst="rect">
               <a:avLst/>
@@ -9044,14 +9047,15 @@
           </p:nvPicPr>
           <p:blipFill>
             <a:blip r:embed="rId21"/>
+            <a:srcRect l="16765" t="16908" r="15413" b="13125"/>
             <a:stretch>
               <a:fillRect/>
             </a:stretch>
           </p:blipFill>
           <p:spPr>
             <a:xfrm>
-              <a:off x="7385846" y="2844906"/>
-              <a:ext cx="1087584" cy="918090"/>
+              <a:off x="7529826" y="2919882"/>
+              <a:ext cx="868205" cy="756079"/>
             </a:xfrm>
             <a:prstGeom prst="rect">
               <a:avLst/>
@@ -9080,8 +9084,8 @@
           </p:blipFill>
           <p:spPr>
             <a:xfrm>
-              <a:off x="6514800" y="2934392"/>
-              <a:ext cx="868533" cy="752729"/>
+              <a:off x="6514800" y="2852188"/>
+              <a:ext cx="963383" cy="834933"/>
             </a:xfrm>
             <a:prstGeom prst="rect">
               <a:avLst/>

</xml_diff>